<commit_message>
update image template Powerpoint
</commit_message>
<xml_diff>
--- a/templates/PostImage.pptx
+++ b/templates/PostImage.pptx
@@ -256,7 +256,7 @@
           <a:p>
             <a:fld id="{A7B99496-28B4-4F48-9C90-51DE3F753911}" type="datetimeFigureOut">
               <a:rPr lang="en-US" smtClean="0"/>
-              <a:t>3/2/26</a:t>
+              <a:t>4/1/26</a:t>
             </a:fld>
             <a:endParaRPr lang="en-US"/>
           </a:p>
@@ -429,7 +429,7 @@
           <a:p>
             <a:fld id="{A7B99496-28B4-4F48-9C90-51DE3F753911}" type="datetimeFigureOut">
               <a:rPr lang="en-US" smtClean="0"/>
-              <a:t>3/2/26</a:t>
+              <a:t>4/1/26</a:t>
             </a:fld>
             <a:endParaRPr lang="en-US"/>
           </a:p>
@@ -612,7 +612,7 @@
           <a:p>
             <a:fld id="{A7B99496-28B4-4F48-9C90-51DE3F753911}" type="datetimeFigureOut">
               <a:rPr lang="en-US" smtClean="0"/>
-              <a:t>3/2/26</a:t>
+              <a:t>4/1/26</a:t>
             </a:fld>
             <a:endParaRPr lang="en-US"/>
           </a:p>
@@ -785,7 +785,7 @@
           <a:p>
             <a:fld id="{A7B99496-28B4-4F48-9C90-51DE3F753911}" type="datetimeFigureOut">
               <a:rPr lang="en-US" smtClean="0"/>
-              <a:t>3/2/26</a:t>
+              <a:t>4/1/26</a:t>
             </a:fld>
             <a:endParaRPr lang="en-US"/>
           </a:p>
@@ -1034,7 +1034,7 @@
           <a:p>
             <a:fld id="{A7B99496-28B4-4F48-9C90-51DE3F753911}" type="datetimeFigureOut">
               <a:rPr lang="en-US" smtClean="0"/>
-              <a:t>3/2/26</a:t>
+              <a:t>4/1/26</a:t>
             </a:fld>
             <a:endParaRPr lang="en-US"/>
           </a:p>
@@ -1269,7 +1269,7 @@
           <a:p>
             <a:fld id="{A7B99496-28B4-4F48-9C90-51DE3F753911}" type="datetimeFigureOut">
               <a:rPr lang="en-US" smtClean="0"/>
-              <a:t>3/2/26</a:t>
+              <a:t>4/1/26</a:t>
             </a:fld>
             <a:endParaRPr lang="en-US"/>
           </a:p>
@@ -1639,7 +1639,7 @@
           <a:p>
             <a:fld id="{A7B99496-28B4-4F48-9C90-51DE3F753911}" type="datetimeFigureOut">
               <a:rPr lang="en-US" smtClean="0"/>
-              <a:t>3/2/26</a:t>
+              <a:t>4/1/26</a:t>
             </a:fld>
             <a:endParaRPr lang="en-US"/>
           </a:p>
@@ -1760,7 +1760,7 @@
           <a:p>
             <a:fld id="{A7B99496-28B4-4F48-9C90-51DE3F753911}" type="datetimeFigureOut">
               <a:rPr lang="en-US" smtClean="0"/>
-              <a:t>3/2/26</a:t>
+              <a:t>4/1/26</a:t>
             </a:fld>
             <a:endParaRPr lang="en-US"/>
           </a:p>
@@ -1858,7 +1858,7 @@
           <a:p>
             <a:fld id="{A7B99496-28B4-4F48-9C90-51DE3F753911}" type="datetimeFigureOut">
               <a:rPr lang="en-US" smtClean="0"/>
-              <a:t>3/2/26</a:t>
+              <a:t>4/1/26</a:t>
             </a:fld>
             <a:endParaRPr lang="en-US"/>
           </a:p>
@@ -2138,7 +2138,7 @@
           <a:p>
             <a:fld id="{A7B99496-28B4-4F48-9C90-51DE3F753911}" type="datetimeFigureOut">
               <a:rPr lang="en-US" smtClean="0"/>
-              <a:t>3/2/26</a:t>
+              <a:t>4/1/26</a:t>
             </a:fld>
             <a:endParaRPr lang="en-US"/>
           </a:p>
@@ -2398,7 +2398,7 @@
           <a:p>
             <a:fld id="{A7B99496-28B4-4F48-9C90-51DE3F753911}" type="datetimeFigureOut">
               <a:rPr lang="en-US" smtClean="0"/>
-              <a:t>3/2/26</a:t>
+              <a:t>4/1/26</a:t>
             </a:fld>
             <a:endParaRPr lang="en-US"/>
           </a:p>
@@ -2614,7 +2614,7 @@
           <a:p>
             <a:fld id="{A7B99496-28B4-4F48-9C90-51DE3F753911}" type="datetimeFigureOut">
               <a:rPr lang="en-US" smtClean="0"/>
-              <a:t>3/2/26</a:t>
+              <a:t>4/1/26</a:t>
             </a:fld>
             <a:endParaRPr lang="en-US"/>
           </a:p>
@@ -3059,29 +3059,29 @@
         </p:nvSpPr>
         <p:spPr>
           <a:xfrm>
-            <a:off x="839593" y="2619833"/>
-            <a:ext cx="10512814" cy="1604991"/>
+            <a:off x="1010369" y="2934634"/>
+            <a:ext cx="10474448" cy="988732"/>
           </a:xfrm>
           <a:noFill/>
         </p:spPr>
         <p:txBody>
-          <a:bodyPr wrap="none">
+          <a:bodyPr wrap="square">
             <a:spAutoFit/>
           </a:bodyPr>
           <a:lstStyle/>
           <a:p>
             <a:r>
-              <a:rPr lang="en-US" sz="5400" b="1" dirty="0">
+              <a:rPr lang="en-US" sz="3200" b="1" dirty="0">
                 <a:solidFill>
                   <a:schemeClr val="bg1"/>
                 </a:solidFill>
                 <a:latin typeface="Avenir Book" panose="02000503020000020003" pitchFamily="2" charset="0"/>
                 <a:cs typeface="Al Nile" pitchFamily="2" charset="-78"/>
               </a:rPr>
-              <a:t>&gt;_Cache Augmented Generation</a:t>
+              <a:t>Building a Governed Agent Orchestration Platform </a:t>
             </a:r>
             <a:br>
-              <a:rPr lang="en-US" sz="5400" b="1" dirty="0">
+              <a:rPr lang="en-US" sz="3200" b="1" dirty="0">
                 <a:solidFill>
                   <a:schemeClr val="bg1"/>
                 </a:solidFill>
@@ -3090,14 +3090,14 @@
               </a:rPr>
             </a:br>
             <a:r>
-              <a:rPr lang="en-US" sz="5400" b="1" dirty="0">
+              <a:rPr lang="en-US" sz="3200" b="1" dirty="0">
                 <a:solidFill>
                   <a:schemeClr val="bg1"/>
                 </a:solidFill>
                 <a:latin typeface="Avenir Book" panose="02000503020000020003" pitchFamily="2" charset="0"/>
                 <a:cs typeface="Al Nile" pitchFamily="2" charset="-78"/>
               </a:rPr>
-              <a:t>and Self Learning Architecture</a:t>
+              <a:t>for Real Operational Work</a:t>
             </a:r>
           </a:p>
         </p:txBody>

</xml_diff>

<commit_message>
post: intelligent control process
</commit_message>
<xml_diff>
--- a/templates/PostImage.pptx
+++ b/templates/PostImage.pptx
@@ -4,10 +4,15 @@
   <p:sldMasterIdLst>
     <p:sldMasterId id="2147483825" r:id="rId1"/>
   </p:sldMasterIdLst>
+  <p:notesMasterIdLst>
+    <p:notesMasterId r:id="rId7"/>
+  </p:notesMasterIdLst>
   <p:sldIdLst>
     <p:sldId id="256" r:id="rId2"/>
-    <p:sldId id="257" r:id="rId3"/>
-    <p:sldId id="258" r:id="rId4"/>
+    <p:sldId id="259" r:id="rId3"/>
+    <p:sldId id="260" r:id="rId4"/>
+    <p:sldId id="257" r:id="rId5"/>
+    <p:sldId id="258" r:id="rId6"/>
   </p:sldIdLst>
   <p:sldSz cx="12192000" cy="6858000"/>
   <p:notesSz cx="6858000" cy="9144000"/>
@@ -125,6 +130,547 @@
 </p:presentation>
 </file>
 
+<file path=ppt/notesMasters/notesMaster1.xml><?xml version="1.0" encoding="utf-8"?>
+<p:notesMaster xmlns:a="http://schemas.openxmlformats.org/drawingml/2006/main" xmlns:r="http://schemas.openxmlformats.org/officeDocument/2006/relationships" xmlns:p="http://schemas.openxmlformats.org/presentationml/2006/main">
+  <p:cSld>
+    <p:bg>
+      <p:bgRef idx="1001">
+        <a:schemeClr val="bg1"/>
+      </p:bgRef>
+    </p:bg>
+    <p:spTree>
+      <p:nvGrpSpPr>
+        <p:cNvPr id="1" name=""/>
+        <p:cNvGrpSpPr/>
+        <p:nvPr/>
+      </p:nvGrpSpPr>
+      <p:grpSpPr>
+        <a:xfrm>
+          <a:off x="0" y="0"/>
+          <a:ext cx="0" cy="0"/>
+          <a:chOff x="0" y="0"/>
+          <a:chExt cx="0" cy="0"/>
+        </a:xfrm>
+      </p:grpSpPr>
+      <p:sp>
+        <p:nvSpPr>
+          <p:cNvPr id="2" name="Header Placeholder 1"/>
+          <p:cNvSpPr>
+            <a:spLocks noGrp="1"/>
+          </p:cNvSpPr>
+          <p:nvPr>
+            <p:ph type="hdr" sz="quarter"/>
+          </p:nvPr>
+        </p:nvSpPr>
+        <p:spPr>
+          <a:xfrm>
+            <a:off x="0" y="0"/>
+            <a:ext cx="2971800" cy="458788"/>
+          </a:xfrm>
+          <a:prstGeom prst="rect">
+            <a:avLst/>
+          </a:prstGeom>
+        </p:spPr>
+        <p:txBody>
+          <a:bodyPr vert="horz" lIns="91440" tIns="45720" rIns="91440" bIns="45720" rtlCol="0"/>
+          <a:lstStyle>
+            <a:lvl1pPr algn="l">
+              <a:defRPr sz="1200"/>
+            </a:lvl1pPr>
+          </a:lstStyle>
+          <a:p>
+            <a:endParaRPr lang="en-US"/>
+          </a:p>
+        </p:txBody>
+      </p:sp>
+      <p:sp>
+        <p:nvSpPr>
+          <p:cNvPr id="3" name="Date Placeholder 2"/>
+          <p:cNvSpPr>
+            <a:spLocks noGrp="1"/>
+          </p:cNvSpPr>
+          <p:nvPr>
+            <p:ph type="dt" idx="1"/>
+          </p:nvPr>
+        </p:nvSpPr>
+        <p:spPr>
+          <a:xfrm>
+            <a:off x="3884613" y="0"/>
+            <a:ext cx="2971800" cy="458788"/>
+          </a:xfrm>
+          <a:prstGeom prst="rect">
+            <a:avLst/>
+          </a:prstGeom>
+        </p:spPr>
+        <p:txBody>
+          <a:bodyPr vert="horz" lIns="91440" tIns="45720" rIns="91440" bIns="45720" rtlCol="0"/>
+          <a:lstStyle>
+            <a:lvl1pPr algn="r">
+              <a:defRPr sz="1200"/>
+            </a:lvl1pPr>
+          </a:lstStyle>
+          <a:p>
+            <a:fld id="{255F66DF-978C-E74D-8F55-69A4D74418C7}" type="datetimeFigureOut">
+              <a:rPr lang="en-US" smtClean="0"/>
+              <a:t>8/27/26</a:t>
+            </a:fld>
+            <a:endParaRPr lang="en-US"/>
+          </a:p>
+        </p:txBody>
+      </p:sp>
+      <p:sp>
+        <p:nvSpPr>
+          <p:cNvPr id="4" name="Slide Image Placeholder 3"/>
+          <p:cNvSpPr>
+            <a:spLocks noGrp="1" noRot="1" noChangeAspect="1"/>
+          </p:cNvSpPr>
+          <p:nvPr>
+            <p:ph type="sldImg" idx="2"/>
+          </p:nvPr>
+        </p:nvSpPr>
+        <p:spPr>
+          <a:xfrm>
+            <a:off x="685800" y="1143000"/>
+            <a:ext cx="5486400" cy="3086100"/>
+          </a:xfrm>
+          <a:prstGeom prst="rect">
+            <a:avLst/>
+          </a:prstGeom>
+          <a:noFill/>
+          <a:ln w="12700">
+            <a:solidFill>
+              <a:prstClr val="black"/>
+            </a:solidFill>
+          </a:ln>
+        </p:spPr>
+        <p:txBody>
+          <a:bodyPr vert="horz" lIns="91440" tIns="45720" rIns="91440" bIns="45720" rtlCol="0" anchor="ctr"/>
+          <a:lstStyle/>
+          <a:p>
+            <a:endParaRPr lang="en-US"/>
+          </a:p>
+        </p:txBody>
+      </p:sp>
+      <p:sp>
+        <p:nvSpPr>
+          <p:cNvPr id="5" name="Notes Placeholder 4"/>
+          <p:cNvSpPr>
+            <a:spLocks noGrp="1"/>
+          </p:cNvSpPr>
+          <p:nvPr>
+            <p:ph type="body" sz="quarter" idx="3"/>
+          </p:nvPr>
+        </p:nvSpPr>
+        <p:spPr>
+          <a:xfrm>
+            <a:off x="685800" y="4400550"/>
+            <a:ext cx="5486400" cy="3600450"/>
+          </a:xfrm>
+          <a:prstGeom prst="rect">
+            <a:avLst/>
+          </a:prstGeom>
+        </p:spPr>
+        <p:txBody>
+          <a:bodyPr vert="horz" lIns="91440" tIns="45720" rIns="91440" bIns="45720" rtlCol="0"/>
+          <a:lstStyle/>
+          <a:p>
+            <a:pPr lvl="0"/>
+            <a:r>
+              <a:rPr lang="en-US"/>
+              <a:t>Click to edit Master text styles</a:t>
+            </a:r>
+          </a:p>
+          <a:p>
+            <a:pPr lvl="1"/>
+            <a:r>
+              <a:rPr lang="en-US"/>
+              <a:t>Second level</a:t>
+            </a:r>
+          </a:p>
+          <a:p>
+            <a:pPr lvl="2"/>
+            <a:r>
+              <a:rPr lang="en-US"/>
+              <a:t>Third level</a:t>
+            </a:r>
+          </a:p>
+          <a:p>
+            <a:pPr lvl="3"/>
+            <a:r>
+              <a:rPr lang="en-US"/>
+              <a:t>Fourth level</a:t>
+            </a:r>
+          </a:p>
+          <a:p>
+            <a:pPr lvl="4"/>
+            <a:r>
+              <a:rPr lang="en-US"/>
+              <a:t>Fifth level</a:t>
+            </a:r>
+          </a:p>
+        </p:txBody>
+      </p:sp>
+      <p:sp>
+        <p:nvSpPr>
+          <p:cNvPr id="6" name="Footer Placeholder 5"/>
+          <p:cNvSpPr>
+            <a:spLocks noGrp="1"/>
+          </p:cNvSpPr>
+          <p:nvPr>
+            <p:ph type="ftr" sz="quarter" idx="4"/>
+          </p:nvPr>
+        </p:nvSpPr>
+        <p:spPr>
+          <a:xfrm>
+            <a:off x="0" y="8685213"/>
+            <a:ext cx="2971800" cy="458787"/>
+          </a:xfrm>
+          <a:prstGeom prst="rect">
+            <a:avLst/>
+          </a:prstGeom>
+        </p:spPr>
+        <p:txBody>
+          <a:bodyPr vert="horz" lIns="91440" tIns="45720" rIns="91440" bIns="45720" rtlCol="0" anchor="b"/>
+          <a:lstStyle>
+            <a:lvl1pPr algn="l">
+              <a:defRPr sz="1200"/>
+            </a:lvl1pPr>
+          </a:lstStyle>
+          <a:p>
+            <a:endParaRPr lang="en-US"/>
+          </a:p>
+        </p:txBody>
+      </p:sp>
+      <p:sp>
+        <p:nvSpPr>
+          <p:cNvPr id="7" name="Slide Number Placeholder 6"/>
+          <p:cNvSpPr>
+            <a:spLocks noGrp="1"/>
+          </p:cNvSpPr>
+          <p:nvPr>
+            <p:ph type="sldNum" sz="quarter" idx="5"/>
+          </p:nvPr>
+        </p:nvSpPr>
+        <p:spPr>
+          <a:xfrm>
+            <a:off x="3884613" y="8685213"/>
+            <a:ext cx="2971800" cy="458787"/>
+          </a:xfrm>
+          <a:prstGeom prst="rect">
+            <a:avLst/>
+          </a:prstGeom>
+        </p:spPr>
+        <p:txBody>
+          <a:bodyPr vert="horz" lIns="91440" tIns="45720" rIns="91440" bIns="45720" rtlCol="0" anchor="b"/>
+          <a:lstStyle>
+            <a:lvl1pPr algn="r">
+              <a:defRPr sz="1200"/>
+            </a:lvl1pPr>
+          </a:lstStyle>
+          <a:p>
+            <a:fld id="{E28A628D-1434-784E-BDFA-8F07A1B299EB}" type="slidenum">
+              <a:rPr lang="en-US" smtClean="0"/>
+              <a:t>‹#›</a:t>
+            </a:fld>
+            <a:endParaRPr lang="en-US"/>
+          </a:p>
+        </p:txBody>
+      </p:sp>
+    </p:spTree>
+    <p:extLst>
+      <p:ext uri="{BB962C8B-B14F-4D97-AF65-F5344CB8AC3E}">
+        <p14:creationId xmlns:p14="http://schemas.microsoft.com/office/powerpoint/2010/main" val="1375926832"/>
+      </p:ext>
+    </p:extLst>
+  </p:cSld>
+  <p:clrMap bg1="lt1" tx1="dk1" bg2="lt2" tx2="dk2" accent1="accent1" accent2="accent2" accent3="accent3" accent4="accent4" accent5="accent5" accent6="accent6" hlink="hlink" folHlink="folHlink"/>
+  <p:notesStyle>
+    <a:lvl1pPr marL="0" algn="l" defTabSz="914400" rtl="0" eaLnBrk="1" latinLnBrk="0" hangingPunct="1">
+      <a:defRPr sz="1200" kern="1200">
+        <a:solidFill>
+          <a:schemeClr val="tx1"/>
+        </a:solidFill>
+        <a:latin typeface="+mn-lt"/>
+        <a:ea typeface="+mn-ea"/>
+        <a:cs typeface="+mn-cs"/>
+      </a:defRPr>
+    </a:lvl1pPr>
+    <a:lvl2pPr marL="457200" algn="l" defTabSz="914400" rtl="0" eaLnBrk="1" latinLnBrk="0" hangingPunct="1">
+      <a:defRPr sz="1200" kern="1200">
+        <a:solidFill>
+          <a:schemeClr val="tx1"/>
+        </a:solidFill>
+        <a:latin typeface="+mn-lt"/>
+        <a:ea typeface="+mn-ea"/>
+        <a:cs typeface="+mn-cs"/>
+      </a:defRPr>
+    </a:lvl2pPr>
+    <a:lvl3pPr marL="914400" algn="l" defTabSz="914400" rtl="0" eaLnBrk="1" latinLnBrk="0" hangingPunct="1">
+      <a:defRPr sz="1200" kern="1200">
+        <a:solidFill>
+          <a:schemeClr val="tx1"/>
+        </a:solidFill>
+        <a:latin typeface="+mn-lt"/>
+        <a:ea typeface="+mn-ea"/>
+        <a:cs typeface="+mn-cs"/>
+      </a:defRPr>
+    </a:lvl3pPr>
+    <a:lvl4pPr marL="1371600" algn="l" defTabSz="914400" rtl="0" eaLnBrk="1" latinLnBrk="0" hangingPunct="1">
+      <a:defRPr sz="1200" kern="1200">
+        <a:solidFill>
+          <a:schemeClr val="tx1"/>
+        </a:solidFill>
+        <a:latin typeface="+mn-lt"/>
+        <a:ea typeface="+mn-ea"/>
+        <a:cs typeface="+mn-cs"/>
+      </a:defRPr>
+    </a:lvl4pPr>
+    <a:lvl5pPr marL="1828800" algn="l" defTabSz="914400" rtl="0" eaLnBrk="1" latinLnBrk="0" hangingPunct="1">
+      <a:defRPr sz="1200" kern="1200">
+        <a:solidFill>
+          <a:schemeClr val="tx1"/>
+        </a:solidFill>
+        <a:latin typeface="+mn-lt"/>
+        <a:ea typeface="+mn-ea"/>
+        <a:cs typeface="+mn-cs"/>
+      </a:defRPr>
+    </a:lvl5pPr>
+    <a:lvl6pPr marL="2286000" algn="l" defTabSz="914400" rtl="0" eaLnBrk="1" latinLnBrk="0" hangingPunct="1">
+      <a:defRPr sz="1200" kern="1200">
+        <a:solidFill>
+          <a:schemeClr val="tx1"/>
+        </a:solidFill>
+        <a:latin typeface="+mn-lt"/>
+        <a:ea typeface="+mn-ea"/>
+        <a:cs typeface="+mn-cs"/>
+      </a:defRPr>
+    </a:lvl6pPr>
+    <a:lvl7pPr marL="2743200" algn="l" defTabSz="914400" rtl="0" eaLnBrk="1" latinLnBrk="0" hangingPunct="1">
+      <a:defRPr sz="1200" kern="1200">
+        <a:solidFill>
+          <a:schemeClr val="tx1"/>
+        </a:solidFill>
+        <a:latin typeface="+mn-lt"/>
+        <a:ea typeface="+mn-ea"/>
+        <a:cs typeface="+mn-cs"/>
+      </a:defRPr>
+    </a:lvl7pPr>
+    <a:lvl8pPr marL="3200400" algn="l" defTabSz="914400" rtl="0" eaLnBrk="1" latinLnBrk="0" hangingPunct="1">
+      <a:defRPr sz="1200" kern="1200">
+        <a:solidFill>
+          <a:schemeClr val="tx1"/>
+        </a:solidFill>
+        <a:latin typeface="+mn-lt"/>
+        <a:ea typeface="+mn-ea"/>
+        <a:cs typeface="+mn-cs"/>
+      </a:defRPr>
+    </a:lvl8pPr>
+    <a:lvl9pPr marL="3657600" algn="l" defTabSz="914400" rtl="0" eaLnBrk="1" latinLnBrk="0" hangingPunct="1">
+      <a:defRPr sz="1200" kern="1200">
+        <a:solidFill>
+          <a:schemeClr val="tx1"/>
+        </a:solidFill>
+        <a:latin typeface="+mn-lt"/>
+        <a:ea typeface="+mn-ea"/>
+        <a:cs typeface="+mn-cs"/>
+      </a:defRPr>
+    </a:lvl9pPr>
+  </p:notesStyle>
+</p:notesMaster>
+</file>
+
+<file path=ppt/notesSlides/notesSlide1.xml><?xml version="1.0" encoding="utf-8"?>
+<p:notes xmlns:a="http://schemas.openxmlformats.org/drawingml/2006/main" xmlns:r="http://schemas.openxmlformats.org/officeDocument/2006/relationships" xmlns:p="http://schemas.openxmlformats.org/presentationml/2006/main">
+  <p:cSld>
+    <p:spTree>
+      <p:nvGrpSpPr>
+        <p:cNvPr id="1" name=""/>
+        <p:cNvGrpSpPr/>
+        <p:nvPr/>
+      </p:nvGrpSpPr>
+      <p:grpSpPr>
+        <a:xfrm>
+          <a:off x="0" y="0"/>
+          <a:ext cx="0" cy="0"/>
+          <a:chOff x="0" y="0"/>
+          <a:chExt cx="0" cy="0"/>
+        </a:xfrm>
+      </p:grpSpPr>
+      <p:sp>
+        <p:nvSpPr>
+          <p:cNvPr id="2" name="Slide Image Placeholder 1"/>
+          <p:cNvSpPr>
+            <a:spLocks noGrp="1" noRot="1" noChangeAspect="1"/>
+          </p:cNvSpPr>
+          <p:nvPr>
+            <p:ph type="sldImg"/>
+          </p:nvPr>
+        </p:nvSpPr>
+        <p:spPr/>
+      </p:sp>
+      <p:sp>
+        <p:nvSpPr>
+          <p:cNvPr id="3" name="Notes Placeholder 2"/>
+          <p:cNvSpPr>
+            <a:spLocks noGrp="1"/>
+          </p:cNvSpPr>
+          <p:nvPr>
+            <p:ph type="body" idx="1"/>
+          </p:nvPr>
+        </p:nvSpPr>
+        <p:spPr/>
+        <p:txBody>
+          <a:bodyPr/>
+          <a:lstStyle/>
+          <a:p>
+            <a:endParaRPr lang="en-US" dirty="0"/>
+          </a:p>
+        </p:txBody>
+      </p:sp>
+      <p:sp>
+        <p:nvSpPr>
+          <p:cNvPr id="4" name="Slide Number Placeholder 3"/>
+          <p:cNvSpPr>
+            <a:spLocks noGrp="1"/>
+          </p:cNvSpPr>
+          <p:nvPr>
+            <p:ph type="sldNum" sz="quarter" idx="10"/>
+          </p:nvPr>
+        </p:nvSpPr>
+        <p:spPr/>
+        <p:txBody>
+          <a:bodyPr/>
+          <a:lstStyle/>
+          <a:p>
+            <a:fld id="{F7021451-1387-4CA6-816F-3879F97B5CBC}" type="slidenum">
+              <a:rPr lang="en-US"/>
+              <a:t>2</a:t>
+            </a:fld>
+            <a:endParaRPr lang="en-US"/>
+          </a:p>
+        </p:txBody>
+      </p:sp>
+    </p:spTree>
+    <p:extLst>
+      <p:ext uri="{BB962C8B-B14F-4D97-AF65-F5344CB8AC3E}">
+        <p14:creationId xmlns:p14="http://schemas.microsoft.com/office/powerpoint/2010/main" val="1024086991"/>
+      </p:ext>
+    </p:extLst>
+  </p:cSld>
+  <p:clrMapOvr>
+    <a:masterClrMapping/>
+  </p:clrMapOvr>
+</p:notes>
+</file>
+
+<file path=ppt/notesSlides/notesSlide2.xml><?xml version="1.0" encoding="utf-8"?>
+<p:notes xmlns:a="http://schemas.openxmlformats.org/drawingml/2006/main" xmlns:r="http://schemas.openxmlformats.org/officeDocument/2006/relationships" xmlns:p="http://schemas.openxmlformats.org/presentationml/2006/main">
+  <p:cSld>
+    <p:spTree>
+      <p:nvGrpSpPr>
+        <p:cNvPr id="1" name="">
+          <a:extLst>
+            <a:ext uri="{FF2B5EF4-FFF2-40B4-BE49-F238E27FC236}">
+              <a16:creationId xmlns:a16="http://schemas.microsoft.com/office/drawing/2014/main" id="{1B0ACF80-9B5D-977B-D30F-AA1CE53B5DF5}"/>
+            </a:ext>
+          </a:extLst>
+        </p:cNvPr>
+        <p:cNvGrpSpPr/>
+        <p:nvPr/>
+      </p:nvGrpSpPr>
+      <p:grpSpPr>
+        <a:xfrm>
+          <a:off x="0" y="0"/>
+          <a:ext cx="0" cy="0"/>
+          <a:chOff x="0" y="0"/>
+          <a:chExt cx="0" cy="0"/>
+        </a:xfrm>
+      </p:grpSpPr>
+      <p:sp>
+        <p:nvSpPr>
+          <p:cNvPr id="2" name="Slide Image Placeholder 1">
+            <a:extLst>
+              <a:ext uri="{FF2B5EF4-FFF2-40B4-BE49-F238E27FC236}">
+                <a16:creationId xmlns:a16="http://schemas.microsoft.com/office/drawing/2014/main" id="{62FA3478-7B74-6955-6B9B-B4552ACB0AE6}"/>
+              </a:ext>
+            </a:extLst>
+          </p:cNvPr>
+          <p:cNvSpPr>
+            <a:spLocks noGrp="1" noRot="1" noChangeAspect="1"/>
+          </p:cNvSpPr>
+          <p:nvPr>
+            <p:ph type="sldImg"/>
+          </p:nvPr>
+        </p:nvSpPr>
+        <p:spPr/>
+      </p:sp>
+      <p:sp>
+        <p:nvSpPr>
+          <p:cNvPr id="3" name="Notes Placeholder 2">
+            <a:extLst>
+              <a:ext uri="{FF2B5EF4-FFF2-40B4-BE49-F238E27FC236}">
+                <a16:creationId xmlns:a16="http://schemas.microsoft.com/office/drawing/2014/main" id="{4F0FD9B3-4DBE-826A-6051-04F2FCC7965F}"/>
+              </a:ext>
+            </a:extLst>
+          </p:cNvPr>
+          <p:cNvSpPr>
+            <a:spLocks noGrp="1"/>
+          </p:cNvSpPr>
+          <p:nvPr>
+            <p:ph type="body" idx="1"/>
+          </p:nvPr>
+        </p:nvSpPr>
+        <p:spPr/>
+        <p:txBody>
+          <a:bodyPr/>
+          <a:lstStyle/>
+          <a:p>
+            <a:endParaRPr lang="en-US" dirty="0"/>
+          </a:p>
+        </p:txBody>
+      </p:sp>
+      <p:sp>
+        <p:nvSpPr>
+          <p:cNvPr id="4" name="Slide Number Placeholder 3">
+            <a:extLst>
+              <a:ext uri="{FF2B5EF4-FFF2-40B4-BE49-F238E27FC236}">
+                <a16:creationId xmlns:a16="http://schemas.microsoft.com/office/drawing/2014/main" id="{F5FB0DFC-B06C-FB19-3309-3702DD5A6297}"/>
+              </a:ext>
+            </a:extLst>
+          </p:cNvPr>
+          <p:cNvSpPr>
+            <a:spLocks noGrp="1"/>
+          </p:cNvSpPr>
+          <p:nvPr>
+            <p:ph type="sldNum" sz="quarter" idx="10"/>
+          </p:nvPr>
+        </p:nvSpPr>
+        <p:spPr/>
+        <p:txBody>
+          <a:bodyPr/>
+          <a:lstStyle/>
+          <a:p>
+            <a:fld id="{F7021451-1387-4CA6-816F-3879F97B5CBC}" type="slidenum">
+              <a:rPr lang="en-US"/>
+              <a:t>3</a:t>
+            </a:fld>
+            <a:endParaRPr lang="en-US"/>
+          </a:p>
+        </p:txBody>
+      </p:sp>
+    </p:spTree>
+    <p:extLst>
+      <p:ext uri="{BB962C8B-B14F-4D97-AF65-F5344CB8AC3E}">
+        <p14:creationId xmlns:p14="http://schemas.microsoft.com/office/powerpoint/2010/main" val="2880706406"/>
+      </p:ext>
+    </p:extLst>
+  </p:cSld>
+  <p:clrMapOvr>
+    <a:masterClrMapping/>
+  </p:clrMapOvr>
+</p:notes>
+</file>
+
 <file path=ppt/slideLayouts/slideLayout1.xml><?xml version="1.0" encoding="utf-8"?>
 <p:sldLayout xmlns:a="http://schemas.openxmlformats.org/drawingml/2006/main" xmlns:r="http://schemas.openxmlformats.org/officeDocument/2006/relationships" xmlns:p="http://schemas.openxmlformats.org/presentationml/2006/main" type="title" preserve="1">
   <p:cSld name="Title Slide">
@@ -256,7 +802,7 @@
           <a:p>
             <a:fld id="{A7B99496-28B4-4F48-9C90-51DE3F753911}" type="datetimeFigureOut">
               <a:rPr lang="en-US" smtClean="0"/>
-              <a:t>4/1/26</a:t>
+              <a:t>8/27/26</a:t>
             </a:fld>
             <a:endParaRPr lang="en-US"/>
           </a:p>
@@ -429,7 +975,7 @@
           <a:p>
             <a:fld id="{A7B99496-28B4-4F48-9C90-51DE3F753911}" type="datetimeFigureOut">
               <a:rPr lang="en-US" smtClean="0"/>
-              <a:t>4/1/26</a:t>
+              <a:t>8/27/26</a:t>
             </a:fld>
             <a:endParaRPr lang="en-US"/>
           </a:p>
@@ -612,7 +1158,7 @@
           <a:p>
             <a:fld id="{A7B99496-28B4-4F48-9C90-51DE3F753911}" type="datetimeFigureOut">
               <a:rPr lang="en-US" smtClean="0"/>
-              <a:t>4/1/26</a:t>
+              <a:t>8/27/26</a:t>
             </a:fld>
             <a:endParaRPr lang="en-US"/>
           </a:p>
@@ -673,6 +1219,41 @@
   <p:transition>
     <p:fade/>
   </p:transition>
+</p:sldLayout>
+</file>
+
+<file path=ppt/slideLayouts/slideLayout12.xml><?xml version="1.0" encoding="utf-8"?>
+<p:sldLayout xmlns:a="http://schemas.openxmlformats.org/drawingml/2006/main" xmlns:r="http://schemas.openxmlformats.org/officeDocument/2006/relationships" xmlns:p="http://schemas.openxmlformats.org/presentationml/2006/main">
+  <p:cSld name="DEFAULT">
+    <p:bg>
+      <p:bgRef idx="1001">
+        <a:schemeClr val="bg1"/>
+      </p:bgRef>
+    </p:bg>
+    <p:spTree>
+      <p:nvGrpSpPr>
+        <p:cNvPr id="1" name=""/>
+        <p:cNvGrpSpPr/>
+        <p:nvPr/>
+      </p:nvGrpSpPr>
+      <p:grpSpPr>
+        <a:xfrm>
+          <a:off x="0" y="0"/>
+          <a:ext cx="0" cy="0"/>
+          <a:chOff x="0" y="0"/>
+          <a:chExt cx="0" cy="0"/>
+        </a:xfrm>
+      </p:grpSpPr>
+    </p:spTree>
+    <p:extLst>
+      <p:ext uri="{BB962C8B-B14F-4D97-AF65-F5344CB8AC3E}">
+        <p14:creationId xmlns:p14="http://schemas.microsoft.com/office/powerpoint/2010/main" val="3026680849"/>
+      </p:ext>
+    </p:extLst>
+  </p:cSld>
+  <p:clrMapOvr>
+    <a:masterClrMapping/>
+  </p:clrMapOvr>
 </p:sldLayout>
 </file>
 
@@ -785,7 +1366,7 @@
           <a:p>
             <a:fld id="{A7B99496-28B4-4F48-9C90-51DE3F753911}" type="datetimeFigureOut">
               <a:rPr lang="en-US" smtClean="0"/>
-              <a:t>4/1/26</a:t>
+              <a:t>8/27/26</a:t>
             </a:fld>
             <a:endParaRPr lang="en-US"/>
           </a:p>
@@ -1034,7 +1615,7 @@
           <a:p>
             <a:fld id="{A7B99496-28B4-4F48-9C90-51DE3F753911}" type="datetimeFigureOut">
               <a:rPr lang="en-US" smtClean="0"/>
-              <a:t>4/1/26</a:t>
+              <a:t>8/27/26</a:t>
             </a:fld>
             <a:endParaRPr lang="en-US"/>
           </a:p>
@@ -1269,7 +1850,7 @@
           <a:p>
             <a:fld id="{A7B99496-28B4-4F48-9C90-51DE3F753911}" type="datetimeFigureOut">
               <a:rPr lang="en-US" smtClean="0"/>
-              <a:t>4/1/26</a:t>
+              <a:t>8/27/26</a:t>
             </a:fld>
             <a:endParaRPr lang="en-US"/>
           </a:p>
@@ -1639,7 +2220,7 @@
           <a:p>
             <a:fld id="{A7B99496-28B4-4F48-9C90-51DE3F753911}" type="datetimeFigureOut">
               <a:rPr lang="en-US" smtClean="0"/>
-              <a:t>4/1/26</a:t>
+              <a:t>8/27/26</a:t>
             </a:fld>
             <a:endParaRPr lang="en-US"/>
           </a:p>
@@ -1760,7 +2341,7 @@
           <a:p>
             <a:fld id="{A7B99496-28B4-4F48-9C90-51DE3F753911}" type="datetimeFigureOut">
               <a:rPr lang="en-US" smtClean="0"/>
-              <a:t>4/1/26</a:t>
+              <a:t>8/27/26</a:t>
             </a:fld>
             <a:endParaRPr lang="en-US"/>
           </a:p>
@@ -1858,7 +2439,7 @@
           <a:p>
             <a:fld id="{A7B99496-28B4-4F48-9C90-51DE3F753911}" type="datetimeFigureOut">
               <a:rPr lang="en-US" smtClean="0"/>
-              <a:t>4/1/26</a:t>
+              <a:t>8/27/26</a:t>
             </a:fld>
             <a:endParaRPr lang="en-US"/>
           </a:p>
@@ -2138,7 +2719,7 @@
           <a:p>
             <a:fld id="{A7B99496-28B4-4F48-9C90-51DE3F753911}" type="datetimeFigureOut">
               <a:rPr lang="en-US" smtClean="0"/>
-              <a:t>4/1/26</a:t>
+              <a:t>8/27/26</a:t>
             </a:fld>
             <a:endParaRPr lang="en-US"/>
           </a:p>
@@ -2398,7 +2979,7 @@
           <a:p>
             <a:fld id="{A7B99496-28B4-4F48-9C90-51DE3F753911}" type="datetimeFigureOut">
               <a:rPr lang="en-US" smtClean="0"/>
-              <a:t>4/1/26</a:t>
+              <a:t>8/27/26</a:t>
             </a:fld>
             <a:endParaRPr lang="en-US"/>
           </a:p>
@@ -2614,7 +3195,7 @@
           <a:p>
             <a:fld id="{A7B99496-28B4-4F48-9C90-51DE3F753911}" type="datetimeFigureOut">
               <a:rPr lang="en-US" smtClean="0"/>
-              <a:t>4/1/26</a:t>
+              <a:t>8/27/26</a:t>
             </a:fld>
             <a:endParaRPr lang="en-US"/>
           </a:p>
@@ -2718,6 +3299,7 @@
     <p:sldLayoutId id="2147483834" r:id="rId9"/>
     <p:sldLayoutId id="2147483835" r:id="rId10"/>
     <p:sldLayoutId id="2147483836" r:id="rId11"/>
+    <p:sldLayoutId id="2147483837" r:id="rId12"/>
   </p:sldLayoutIdLst>
   <p:transition>
     <p:fade/>
@@ -3254,6 +3836,1065 @@
     <p:bg>
       <p:bgPr>
         <a:solidFill>
+          <a:schemeClr val="tx2"/>
+        </a:solidFill>
+        <a:effectLst/>
+      </p:bgPr>
+    </p:bg>
+    <p:spTree>
+      <p:nvGrpSpPr>
+        <p:cNvPr id="1" name=""/>
+        <p:cNvGrpSpPr/>
+        <p:nvPr/>
+      </p:nvGrpSpPr>
+      <p:grpSpPr>
+        <a:xfrm>
+          <a:off x="0" y="0"/>
+          <a:ext cx="0" cy="0"/>
+          <a:chOff x="0" y="0"/>
+          <a:chExt cx="0" cy="0"/>
+        </a:xfrm>
+      </p:grpSpPr>
+      <p:sp>
+        <p:nvSpPr>
+          <p:cNvPr id="2" name="Shape 0"/>
+          <p:cNvSpPr/>
+          <p:nvPr/>
+        </p:nvSpPr>
+        <p:spPr>
+          <a:xfrm>
+            <a:off x="8290560" y="0"/>
+            <a:ext cx="3901440" cy="6858000"/>
+          </a:xfrm>
+          <a:prstGeom prst="rect">
+            <a:avLst/>
+          </a:prstGeom>
+          <a:solidFill>
+            <a:srgbClr val="1F47AC"/>
+          </a:solidFill>
+          <a:ln w="12700">
+            <a:solidFill>
+              <a:srgbClr val="1F47AC"/>
+            </a:solidFill>
+            <a:prstDash val="solid"/>
+          </a:ln>
+        </p:spPr>
+        <p:txBody>
+          <a:bodyPr/>
+          <a:lstStyle/>
+          <a:p>
+            <a:endParaRPr lang="en-US" sz="2400"/>
+          </a:p>
+        </p:txBody>
+      </p:sp>
+      <p:sp>
+        <p:nvSpPr>
+          <p:cNvPr id="3" name="Shape 1"/>
+          <p:cNvSpPr/>
+          <p:nvPr/>
+        </p:nvSpPr>
+        <p:spPr>
+          <a:xfrm>
+            <a:off x="8046720" y="0"/>
+            <a:ext cx="243840" cy="6858000"/>
+          </a:xfrm>
+          <a:prstGeom prst="rect">
+            <a:avLst/>
+          </a:prstGeom>
+          <a:solidFill>
+            <a:srgbClr val="0080FF"/>
+          </a:solidFill>
+          <a:ln w="12700">
+            <a:solidFill>
+              <a:srgbClr val="0080FF"/>
+            </a:solidFill>
+            <a:prstDash val="solid"/>
+          </a:ln>
+        </p:spPr>
+        <p:txBody>
+          <a:bodyPr/>
+          <a:lstStyle/>
+          <a:p>
+            <a:endParaRPr lang="en-US" sz="2400"/>
+          </a:p>
+        </p:txBody>
+      </p:sp>
+      <p:sp>
+        <p:nvSpPr>
+          <p:cNvPr id="4" name="Shape 2"/>
+          <p:cNvSpPr/>
+          <p:nvPr/>
+        </p:nvSpPr>
+        <p:spPr>
+          <a:xfrm>
+            <a:off x="548640" y="914400"/>
+            <a:ext cx="146304" cy="4267200"/>
+          </a:xfrm>
+          <a:prstGeom prst="rect">
+            <a:avLst/>
+          </a:prstGeom>
+          <a:solidFill>
+            <a:srgbClr val="0080FF"/>
+          </a:solidFill>
+          <a:ln w="12700">
+            <a:solidFill>
+              <a:srgbClr val="0080FF"/>
+            </a:solidFill>
+            <a:prstDash val="solid"/>
+          </a:ln>
+        </p:spPr>
+        <p:txBody>
+          <a:bodyPr/>
+          <a:lstStyle/>
+          <a:p>
+            <a:endParaRPr lang="en-US" sz="2400"/>
+          </a:p>
+        </p:txBody>
+      </p:sp>
+      <p:sp>
+        <p:nvSpPr>
+          <p:cNvPr id="5" name="Text 3"/>
+          <p:cNvSpPr/>
+          <p:nvPr/>
+        </p:nvSpPr>
+        <p:spPr>
+          <a:xfrm>
+            <a:off x="914400" y="999744"/>
+            <a:ext cx="6827520" cy="633984"/>
+          </a:xfrm>
+          <a:prstGeom prst="rect">
+            <a:avLst/>
+          </a:prstGeom>
+          <a:noFill/>
+          <a:ln/>
+        </p:spPr>
+        <p:txBody>
+          <a:bodyPr wrap="square" lIns="0" tIns="0" rIns="0" bIns="0" rtlCol="0" anchor="ctr"/>
+          <a:lstStyle/>
+          <a:p>
+            <a:r>
+              <a:rPr lang="en-US" sz="1600" b="1" kern="0" spc="667" dirty="0">
+                <a:solidFill>
+                  <a:srgbClr val="0080FF"/>
+                </a:solidFill>
+                <a:latin typeface="Helvetica Neue" pitchFamily="34" charset="0"/>
+                <a:ea typeface="Helvetica Neue" pitchFamily="34" charset="-122"/>
+                <a:cs typeface="Helvetica Neue" pitchFamily="34" charset="-120"/>
+              </a:rPr>
+              <a:t>Applied AI</a:t>
+            </a:r>
+            <a:endParaRPr lang="en-US" sz="1600" dirty="0"/>
+          </a:p>
+        </p:txBody>
+      </p:sp>
+      <p:sp>
+        <p:nvSpPr>
+          <p:cNvPr id="6" name="Text 4"/>
+          <p:cNvSpPr/>
+          <p:nvPr/>
+        </p:nvSpPr>
+        <p:spPr>
+          <a:xfrm>
+            <a:off x="914400" y="1731264"/>
+            <a:ext cx="7071360" cy="2438400"/>
+          </a:xfrm>
+          <a:prstGeom prst="rect">
+            <a:avLst/>
+          </a:prstGeom>
+          <a:noFill/>
+          <a:ln/>
+        </p:spPr>
+        <p:txBody>
+          <a:bodyPr wrap="square" lIns="0" tIns="0" rIns="0" bIns="0" rtlCol="0" anchor="ctr"/>
+          <a:lstStyle/>
+          <a:p>
+            <a:r>
+              <a:rPr lang="en-US" sz="4533" b="1" dirty="0">
+                <a:solidFill>
+                  <a:srgbClr val="FFFFFF"/>
+                </a:solidFill>
+                <a:latin typeface="Helvetica Neue" pitchFamily="34" charset="0"/>
+                <a:ea typeface="Helvetica Neue" pitchFamily="34" charset="-122"/>
+                <a:cs typeface="Helvetica Neue" pitchFamily="34" charset="-120"/>
+              </a:rPr>
+              <a:t>Intelligent Control Process</a:t>
+            </a:r>
+            <a:endParaRPr lang="en-US" sz="4533" dirty="0"/>
+          </a:p>
+        </p:txBody>
+      </p:sp>
+      <p:sp>
+        <p:nvSpPr>
+          <p:cNvPr id="7" name="Text 5"/>
+          <p:cNvSpPr/>
+          <p:nvPr/>
+        </p:nvSpPr>
+        <p:spPr>
+          <a:xfrm>
+            <a:off x="914400" y="4267200"/>
+            <a:ext cx="7071360" cy="463296"/>
+          </a:xfrm>
+          <a:prstGeom prst="rect">
+            <a:avLst/>
+          </a:prstGeom>
+          <a:noFill/>
+          <a:ln/>
+        </p:spPr>
+        <p:txBody>
+          <a:bodyPr wrap="square" lIns="0" tIns="0" rIns="0" bIns="0" rtlCol="0" anchor="ctr"/>
+          <a:lstStyle/>
+          <a:p>
+            <a:r>
+              <a:rPr lang="en-US" sz="1733" dirty="0">
+                <a:solidFill>
+                  <a:srgbClr val="AACCFF"/>
+                </a:solidFill>
+                <a:latin typeface="Helvetica Neue" pitchFamily="34" charset="0"/>
+                <a:ea typeface="Helvetica Neue" pitchFamily="34" charset="-122"/>
+                <a:cs typeface="Helvetica Neue" pitchFamily="34" charset="-120"/>
+              </a:rPr>
+              <a:t>Mark Roxberry</a:t>
+            </a:r>
+            <a:endParaRPr lang="en-US" sz="1733" dirty="0"/>
+          </a:p>
+        </p:txBody>
+      </p:sp>
+      <p:sp>
+        <p:nvSpPr>
+          <p:cNvPr id="8" name="Text 6"/>
+          <p:cNvSpPr/>
+          <p:nvPr/>
+        </p:nvSpPr>
+        <p:spPr>
+          <a:xfrm>
+            <a:off x="8522208" y="1944622"/>
+            <a:ext cx="3413760" cy="548640"/>
+          </a:xfrm>
+          <a:prstGeom prst="rect">
+            <a:avLst/>
+          </a:prstGeom>
+          <a:noFill/>
+          <a:ln/>
+        </p:spPr>
+        <p:txBody>
+          <a:bodyPr wrap="square" lIns="0" tIns="0" rIns="0" bIns="0" rtlCol="0" anchor="ctr"/>
+          <a:lstStyle/>
+          <a:p>
+            <a:pPr algn="ctr"/>
+            <a:r>
+              <a:rPr lang="en-US" sz="2667" b="1" dirty="0">
+                <a:solidFill>
+                  <a:srgbClr val="FFFFFF"/>
+                </a:solidFill>
+                <a:latin typeface="Helvetica Neue" pitchFamily="34" charset="0"/>
+                <a:ea typeface="Helvetica Neue" pitchFamily="34" charset="-122"/>
+                <a:cs typeface="Helvetica Neue" pitchFamily="34" charset="-120"/>
+              </a:rPr>
+              <a:t>Governed Delivery</a:t>
+            </a:r>
+            <a:endParaRPr lang="en-US" sz="2667" dirty="0"/>
+          </a:p>
+        </p:txBody>
+      </p:sp>
+      <p:sp>
+        <p:nvSpPr>
+          <p:cNvPr id="9" name="Text 7"/>
+          <p:cNvSpPr/>
+          <p:nvPr/>
+        </p:nvSpPr>
+        <p:spPr>
+          <a:xfrm>
+            <a:off x="8534400" y="2584702"/>
+            <a:ext cx="3413760" cy="390144"/>
+          </a:xfrm>
+          <a:prstGeom prst="rect">
+            <a:avLst/>
+          </a:prstGeom>
+          <a:noFill/>
+          <a:ln/>
+        </p:spPr>
+        <p:txBody>
+          <a:bodyPr wrap="square" lIns="0" tIns="0" rIns="0" bIns="0" rtlCol="0" anchor="ctr"/>
+          <a:lstStyle/>
+          <a:p>
+            <a:pPr algn="ctr"/>
+            <a:r>
+              <a:rPr lang="en-US" sz="1333" i="1" dirty="0">
+                <a:solidFill>
+                  <a:srgbClr val="AACCFF"/>
+                </a:solidFill>
+                <a:latin typeface="Helvetica Neue" pitchFamily="34" charset="0"/>
+                <a:ea typeface="Helvetica Neue" pitchFamily="34" charset="-122"/>
+                <a:cs typeface="Helvetica Neue" pitchFamily="34" charset="-120"/>
+              </a:rPr>
+              <a:t>Review Driven Execution</a:t>
+            </a:r>
+            <a:endParaRPr lang="en-US" sz="1333" dirty="0"/>
+          </a:p>
+        </p:txBody>
+      </p:sp>
+      <p:sp>
+        <p:nvSpPr>
+          <p:cNvPr id="10" name="Shape 8"/>
+          <p:cNvSpPr/>
+          <p:nvPr/>
+        </p:nvSpPr>
+        <p:spPr>
+          <a:xfrm>
+            <a:off x="8887968" y="3134751"/>
+            <a:ext cx="2682240" cy="0"/>
+          </a:xfrm>
+          <a:prstGeom prst="line">
+            <a:avLst/>
+          </a:prstGeom>
+          <a:noFill/>
+          <a:ln w="10160">
+            <a:solidFill>
+              <a:srgbClr val="0080FF"/>
+            </a:solidFill>
+            <a:prstDash val="solid"/>
+          </a:ln>
+        </p:spPr>
+        <p:txBody>
+          <a:bodyPr/>
+          <a:lstStyle/>
+          <a:p>
+            <a:endParaRPr lang="en-US" sz="2400"/>
+          </a:p>
+        </p:txBody>
+      </p:sp>
+      <p:sp>
+        <p:nvSpPr>
+          <p:cNvPr id="11" name="Text 9"/>
+          <p:cNvSpPr/>
+          <p:nvPr/>
+        </p:nvSpPr>
+        <p:spPr>
+          <a:xfrm>
+            <a:off x="8522208" y="3261360"/>
+            <a:ext cx="3413760" cy="914396"/>
+          </a:xfrm>
+          <a:prstGeom prst="rect">
+            <a:avLst/>
+          </a:prstGeom>
+          <a:noFill/>
+          <a:ln/>
+        </p:spPr>
+        <p:txBody>
+          <a:bodyPr wrap="square" lIns="0" tIns="0" rIns="0" bIns="0" rtlCol="0" anchor="ctr"/>
+          <a:lstStyle/>
+          <a:p>
+            <a:pPr algn="ctr"/>
+            <a:r>
+              <a:rPr lang="en-US" sz="2667" b="1" dirty="0">
+                <a:solidFill>
+                  <a:srgbClr val="FFFFFF"/>
+                </a:solidFill>
+                <a:latin typeface="Helvetica Neue" pitchFamily="34" charset="0"/>
+                <a:ea typeface="Helvetica Neue" pitchFamily="34" charset="-122"/>
+                <a:cs typeface="Helvetica Neue" pitchFamily="34" charset="-120"/>
+              </a:rPr>
+              <a:t>Human Accountability</a:t>
+            </a:r>
+            <a:endParaRPr lang="en-US" sz="2667" dirty="0"/>
+          </a:p>
+        </p:txBody>
+      </p:sp>
+      <p:sp>
+        <p:nvSpPr>
+          <p:cNvPr id="12" name="Text 10"/>
+          <p:cNvSpPr/>
+          <p:nvPr/>
+        </p:nvSpPr>
+        <p:spPr>
+          <a:xfrm>
+            <a:off x="8534400" y="4108702"/>
+            <a:ext cx="3413760" cy="548639"/>
+          </a:xfrm>
+          <a:prstGeom prst="rect">
+            <a:avLst/>
+          </a:prstGeom>
+          <a:noFill/>
+          <a:ln/>
+        </p:spPr>
+        <p:txBody>
+          <a:bodyPr wrap="square" lIns="0" tIns="0" rIns="0" bIns="0" rtlCol="0" anchor="ctr"/>
+          <a:lstStyle/>
+          <a:p>
+            <a:pPr algn="ctr"/>
+            <a:r>
+              <a:rPr lang="en-US" sz="1333" i="1" dirty="0">
+                <a:solidFill>
+                  <a:srgbClr val="AACCFF"/>
+                </a:solidFill>
+                <a:latin typeface="Helvetica Neue" pitchFamily="34" charset="0"/>
+                <a:ea typeface="Helvetica Neue" pitchFamily="34" charset="-122"/>
+                <a:cs typeface="Helvetica Neue" pitchFamily="34" charset="-120"/>
+              </a:rPr>
+              <a:t>Observability at Every Decision Point</a:t>
+            </a:r>
+            <a:endParaRPr lang="en-US" sz="1333" dirty="0"/>
+          </a:p>
+        </p:txBody>
+      </p:sp>
+    </p:spTree>
+  </p:cSld>
+  <p:clrMapOvr>
+    <a:masterClrMapping/>
+  </p:clrMapOvr>
+</p:sld>
+</file>
+
+<file path=ppt/slides/slide3.xml><?xml version="1.0" encoding="utf-8"?>
+<p:sld xmlns:a="http://schemas.openxmlformats.org/drawingml/2006/main" xmlns:r="http://schemas.openxmlformats.org/officeDocument/2006/relationships" xmlns:p="http://schemas.openxmlformats.org/presentationml/2006/main">
+  <p:cSld>
+    <p:bg>
+      <p:bgPr>
+        <a:solidFill>
+          <a:schemeClr val="tx2"/>
+        </a:solidFill>
+        <a:effectLst/>
+      </p:bgPr>
+    </p:bg>
+    <p:spTree>
+      <p:nvGrpSpPr>
+        <p:cNvPr id="1" name="">
+          <a:extLst>
+            <a:ext uri="{FF2B5EF4-FFF2-40B4-BE49-F238E27FC236}">
+              <a16:creationId xmlns:a16="http://schemas.microsoft.com/office/drawing/2014/main" id="{98E0B1B3-A01F-ADF9-BE8B-FC9E7F6CC4B9}"/>
+            </a:ext>
+          </a:extLst>
+        </p:cNvPr>
+        <p:cNvGrpSpPr/>
+        <p:nvPr/>
+      </p:nvGrpSpPr>
+      <p:grpSpPr>
+        <a:xfrm>
+          <a:off x="0" y="0"/>
+          <a:ext cx="0" cy="0"/>
+          <a:chOff x="0" y="0"/>
+          <a:chExt cx="0" cy="0"/>
+        </a:xfrm>
+      </p:grpSpPr>
+      <p:sp>
+        <p:nvSpPr>
+          <p:cNvPr id="2" name="Shape 0">
+            <a:extLst>
+              <a:ext uri="{FF2B5EF4-FFF2-40B4-BE49-F238E27FC236}">
+                <a16:creationId xmlns:a16="http://schemas.microsoft.com/office/drawing/2014/main" id="{E4060F5B-7390-4E5C-8B67-17634707ECE8}"/>
+              </a:ext>
+            </a:extLst>
+          </p:cNvPr>
+          <p:cNvSpPr/>
+          <p:nvPr/>
+        </p:nvSpPr>
+        <p:spPr>
+          <a:xfrm>
+            <a:off x="8290560" y="0"/>
+            <a:ext cx="3901440" cy="6858000"/>
+          </a:xfrm>
+          <a:prstGeom prst="rect">
+            <a:avLst/>
+          </a:prstGeom>
+          <a:solidFill>
+            <a:srgbClr val="1F47AC"/>
+          </a:solidFill>
+          <a:ln w="12700">
+            <a:solidFill>
+              <a:srgbClr val="1F47AC"/>
+            </a:solidFill>
+            <a:prstDash val="solid"/>
+          </a:ln>
+        </p:spPr>
+        <p:txBody>
+          <a:bodyPr/>
+          <a:lstStyle/>
+          <a:p>
+            <a:endParaRPr lang="en-US" sz="2400"/>
+          </a:p>
+        </p:txBody>
+      </p:sp>
+      <p:sp>
+        <p:nvSpPr>
+          <p:cNvPr id="3" name="Shape 1">
+            <a:extLst>
+              <a:ext uri="{FF2B5EF4-FFF2-40B4-BE49-F238E27FC236}">
+                <a16:creationId xmlns:a16="http://schemas.microsoft.com/office/drawing/2014/main" id="{AC43D4A1-6CF5-31B8-EC49-04D24DC184CB}"/>
+              </a:ext>
+            </a:extLst>
+          </p:cNvPr>
+          <p:cNvSpPr/>
+          <p:nvPr/>
+        </p:nvSpPr>
+        <p:spPr>
+          <a:xfrm>
+            <a:off x="8046720" y="0"/>
+            <a:ext cx="243840" cy="6858000"/>
+          </a:xfrm>
+          <a:prstGeom prst="rect">
+            <a:avLst/>
+          </a:prstGeom>
+          <a:solidFill>
+            <a:srgbClr val="0080FF"/>
+          </a:solidFill>
+          <a:ln w="12700">
+            <a:solidFill>
+              <a:srgbClr val="0080FF"/>
+            </a:solidFill>
+            <a:prstDash val="solid"/>
+          </a:ln>
+        </p:spPr>
+        <p:txBody>
+          <a:bodyPr/>
+          <a:lstStyle/>
+          <a:p>
+            <a:endParaRPr lang="en-US" sz="2400"/>
+          </a:p>
+        </p:txBody>
+      </p:sp>
+      <p:sp>
+        <p:nvSpPr>
+          <p:cNvPr id="4" name="Shape 2">
+            <a:extLst>
+              <a:ext uri="{FF2B5EF4-FFF2-40B4-BE49-F238E27FC236}">
+                <a16:creationId xmlns:a16="http://schemas.microsoft.com/office/drawing/2014/main" id="{917F5363-1F77-FD0B-E4B2-C38F92A44B52}"/>
+              </a:ext>
+            </a:extLst>
+          </p:cNvPr>
+          <p:cNvSpPr/>
+          <p:nvPr/>
+        </p:nvSpPr>
+        <p:spPr>
+          <a:xfrm>
+            <a:off x="548640" y="914400"/>
+            <a:ext cx="146304" cy="4267200"/>
+          </a:xfrm>
+          <a:prstGeom prst="rect">
+            <a:avLst/>
+          </a:prstGeom>
+          <a:solidFill>
+            <a:srgbClr val="0080FF"/>
+          </a:solidFill>
+          <a:ln w="12700">
+            <a:solidFill>
+              <a:srgbClr val="0080FF"/>
+            </a:solidFill>
+            <a:prstDash val="solid"/>
+          </a:ln>
+        </p:spPr>
+        <p:txBody>
+          <a:bodyPr/>
+          <a:lstStyle/>
+          <a:p>
+            <a:endParaRPr lang="en-US" sz="2400"/>
+          </a:p>
+        </p:txBody>
+      </p:sp>
+      <p:sp>
+        <p:nvSpPr>
+          <p:cNvPr id="5" name="Text 3">
+            <a:extLst>
+              <a:ext uri="{FF2B5EF4-FFF2-40B4-BE49-F238E27FC236}">
+                <a16:creationId xmlns:a16="http://schemas.microsoft.com/office/drawing/2014/main" id="{03441A9D-5CE9-CB75-B563-F426470E8722}"/>
+              </a:ext>
+            </a:extLst>
+          </p:cNvPr>
+          <p:cNvSpPr/>
+          <p:nvPr/>
+        </p:nvSpPr>
+        <p:spPr>
+          <a:xfrm>
+            <a:off x="914400" y="999744"/>
+            <a:ext cx="6827520" cy="633984"/>
+          </a:xfrm>
+          <a:prstGeom prst="rect">
+            <a:avLst/>
+          </a:prstGeom>
+          <a:noFill/>
+          <a:ln/>
+        </p:spPr>
+        <p:txBody>
+          <a:bodyPr wrap="square" lIns="0" tIns="0" rIns="0" bIns="0" rtlCol="0" anchor="ctr"/>
+          <a:lstStyle/>
+          <a:p>
+            <a:r>
+              <a:rPr lang="en-US" sz="1600" b="1" kern="0" spc="667" dirty="0">
+                <a:solidFill>
+                  <a:srgbClr val="0080FF"/>
+                </a:solidFill>
+                <a:latin typeface="Helvetica Neue" pitchFamily="34" charset="0"/>
+                <a:ea typeface="Helvetica Neue" pitchFamily="34" charset="-122"/>
+                <a:cs typeface="Helvetica Neue" pitchFamily="34" charset="-120"/>
+              </a:rPr>
+              <a:t>PROJECT NAUTILUS</a:t>
+            </a:r>
+            <a:endParaRPr lang="en-US" sz="1600" dirty="0"/>
+          </a:p>
+        </p:txBody>
+      </p:sp>
+      <p:sp>
+        <p:nvSpPr>
+          <p:cNvPr id="6" name="Text 4">
+            <a:extLst>
+              <a:ext uri="{FF2B5EF4-FFF2-40B4-BE49-F238E27FC236}">
+                <a16:creationId xmlns:a16="http://schemas.microsoft.com/office/drawing/2014/main" id="{85B1D7B0-1D3A-00AC-1C95-0A3A9BF0929C}"/>
+              </a:ext>
+            </a:extLst>
+          </p:cNvPr>
+          <p:cNvSpPr/>
+          <p:nvPr/>
+        </p:nvSpPr>
+        <p:spPr>
+          <a:xfrm>
+            <a:off x="914400" y="1731264"/>
+            <a:ext cx="7071360" cy="2438400"/>
+          </a:xfrm>
+          <a:prstGeom prst="rect">
+            <a:avLst/>
+          </a:prstGeom>
+          <a:noFill/>
+          <a:ln/>
+        </p:spPr>
+        <p:txBody>
+          <a:bodyPr wrap="square" lIns="0" tIns="0" rIns="0" bIns="0" rtlCol="0" anchor="ctr"/>
+          <a:lstStyle/>
+          <a:p>
+            <a:r>
+              <a:rPr lang="en-US" sz="4533" b="1" dirty="0">
+                <a:solidFill>
+                  <a:srgbClr val="FFFFFF"/>
+                </a:solidFill>
+                <a:latin typeface="Helvetica Neue" pitchFamily="34" charset="0"/>
+                <a:ea typeface="Helvetica Neue" pitchFamily="34" charset="-122"/>
+                <a:cs typeface="Helvetica Neue" pitchFamily="34" charset="-120"/>
+              </a:rPr>
+              <a:t>Intelligent Control Process</a:t>
+            </a:r>
+            <a:endParaRPr lang="en-US" sz="4533" dirty="0"/>
+          </a:p>
+        </p:txBody>
+      </p:sp>
+      <p:sp>
+        <p:nvSpPr>
+          <p:cNvPr id="7" name="Text 5">
+            <a:extLst>
+              <a:ext uri="{FF2B5EF4-FFF2-40B4-BE49-F238E27FC236}">
+                <a16:creationId xmlns:a16="http://schemas.microsoft.com/office/drawing/2014/main" id="{DD4997D2-236E-6AE2-A9A5-79F512BB01BE}"/>
+              </a:ext>
+            </a:extLst>
+          </p:cNvPr>
+          <p:cNvSpPr/>
+          <p:nvPr/>
+        </p:nvSpPr>
+        <p:spPr>
+          <a:xfrm>
+            <a:off x="914400" y="4267200"/>
+            <a:ext cx="7071360" cy="463296"/>
+          </a:xfrm>
+          <a:prstGeom prst="rect">
+            <a:avLst/>
+          </a:prstGeom>
+          <a:noFill/>
+          <a:ln/>
+        </p:spPr>
+        <p:txBody>
+          <a:bodyPr wrap="square" lIns="0" tIns="0" rIns="0" bIns="0" rtlCol="0" anchor="ctr"/>
+          <a:lstStyle/>
+          <a:p>
+            <a:r>
+              <a:rPr lang="en-US" sz="1733" dirty="0">
+                <a:solidFill>
+                  <a:srgbClr val="AACCFF"/>
+                </a:solidFill>
+                <a:latin typeface="Helvetica Neue" pitchFamily="34" charset="0"/>
+                <a:ea typeface="Helvetica Neue" pitchFamily="34" charset="-122"/>
+                <a:cs typeface="Helvetica Neue" pitchFamily="34" charset="-120"/>
+              </a:rPr>
+              <a:t>Presented to Oceans Casino Resort</a:t>
+            </a:r>
+            <a:endParaRPr lang="en-US" sz="1733" dirty="0"/>
+          </a:p>
+        </p:txBody>
+      </p:sp>
+      <p:sp>
+        <p:nvSpPr>
+          <p:cNvPr id="8" name="Text 6">
+            <a:extLst>
+              <a:ext uri="{FF2B5EF4-FFF2-40B4-BE49-F238E27FC236}">
+                <a16:creationId xmlns:a16="http://schemas.microsoft.com/office/drawing/2014/main" id="{24C34AE6-B868-A876-5FAD-74C5B3F85A67}"/>
+              </a:ext>
+            </a:extLst>
+          </p:cNvPr>
+          <p:cNvSpPr/>
+          <p:nvPr/>
+        </p:nvSpPr>
+        <p:spPr>
+          <a:xfrm>
+            <a:off x="8534400" y="1463040"/>
+            <a:ext cx="3413760" cy="548640"/>
+          </a:xfrm>
+          <a:prstGeom prst="rect">
+            <a:avLst/>
+          </a:prstGeom>
+          <a:noFill/>
+          <a:ln/>
+        </p:spPr>
+        <p:txBody>
+          <a:bodyPr wrap="square" lIns="0" tIns="0" rIns="0" bIns="0" rtlCol="0" anchor="ctr"/>
+          <a:lstStyle/>
+          <a:p>
+            <a:pPr algn="ctr"/>
+            <a:r>
+              <a:rPr lang="en-US" sz="2667" b="1" dirty="0">
+                <a:solidFill>
+                  <a:srgbClr val="FFFFFF"/>
+                </a:solidFill>
+                <a:latin typeface="Helvetica Neue" pitchFamily="34" charset="0"/>
+                <a:ea typeface="Helvetica Neue" pitchFamily="34" charset="-122"/>
+                <a:cs typeface="Helvetica Neue" pitchFamily="34" charset="-120"/>
+              </a:rPr>
+              <a:t>Governed Delivery</a:t>
+            </a:r>
+            <a:endParaRPr lang="en-US" sz="2667" dirty="0"/>
+          </a:p>
+        </p:txBody>
+      </p:sp>
+      <p:sp>
+        <p:nvSpPr>
+          <p:cNvPr id="9" name="Text 7">
+            <a:extLst>
+              <a:ext uri="{FF2B5EF4-FFF2-40B4-BE49-F238E27FC236}">
+                <a16:creationId xmlns:a16="http://schemas.microsoft.com/office/drawing/2014/main" id="{D482C03E-6547-E2A7-79F5-43E6650A47F6}"/>
+              </a:ext>
+            </a:extLst>
+          </p:cNvPr>
+          <p:cNvSpPr/>
+          <p:nvPr/>
+        </p:nvSpPr>
+        <p:spPr>
+          <a:xfrm>
+            <a:off x="8534400" y="2011680"/>
+            <a:ext cx="3413760" cy="390144"/>
+          </a:xfrm>
+          <a:prstGeom prst="rect">
+            <a:avLst/>
+          </a:prstGeom>
+          <a:noFill/>
+          <a:ln/>
+        </p:spPr>
+        <p:txBody>
+          <a:bodyPr wrap="square" lIns="0" tIns="0" rIns="0" bIns="0" rtlCol="0" anchor="ctr"/>
+          <a:lstStyle/>
+          <a:p>
+            <a:pPr algn="ctr"/>
+            <a:r>
+              <a:rPr lang="en-US" sz="1333" i="1" dirty="0">
+                <a:solidFill>
+                  <a:srgbClr val="AACCFF"/>
+                </a:solidFill>
+                <a:latin typeface="Helvetica Neue" pitchFamily="34" charset="0"/>
+                <a:ea typeface="Helvetica Neue" pitchFamily="34" charset="-122"/>
+                <a:cs typeface="Helvetica Neue" pitchFamily="34" charset="-120"/>
+              </a:rPr>
+              <a:t>Review Driven Execution</a:t>
+            </a:r>
+            <a:endParaRPr lang="en-US" sz="1333" dirty="0"/>
+          </a:p>
+        </p:txBody>
+      </p:sp>
+      <p:sp>
+        <p:nvSpPr>
+          <p:cNvPr id="10" name="Shape 8">
+            <a:extLst>
+              <a:ext uri="{FF2B5EF4-FFF2-40B4-BE49-F238E27FC236}">
+                <a16:creationId xmlns:a16="http://schemas.microsoft.com/office/drawing/2014/main" id="{651D2333-65BA-8C91-1D75-AC76B22B1246}"/>
+              </a:ext>
+            </a:extLst>
+          </p:cNvPr>
+          <p:cNvSpPr/>
+          <p:nvPr/>
+        </p:nvSpPr>
+        <p:spPr>
+          <a:xfrm>
+            <a:off x="8900160" y="2560320"/>
+            <a:ext cx="2682240" cy="0"/>
+          </a:xfrm>
+          <a:prstGeom prst="line">
+            <a:avLst/>
+          </a:prstGeom>
+          <a:noFill/>
+          <a:ln w="10160">
+            <a:solidFill>
+              <a:srgbClr val="0080FF"/>
+            </a:solidFill>
+            <a:prstDash val="solid"/>
+          </a:ln>
+        </p:spPr>
+        <p:txBody>
+          <a:bodyPr/>
+          <a:lstStyle/>
+          <a:p>
+            <a:endParaRPr lang="en-US" sz="2400"/>
+          </a:p>
+        </p:txBody>
+      </p:sp>
+      <p:sp>
+        <p:nvSpPr>
+          <p:cNvPr id="11" name="Text 9">
+            <a:extLst>
+              <a:ext uri="{FF2B5EF4-FFF2-40B4-BE49-F238E27FC236}">
+                <a16:creationId xmlns:a16="http://schemas.microsoft.com/office/drawing/2014/main" id="{D7E74EB9-E8F3-7280-2543-6157A18EA286}"/>
+              </a:ext>
+            </a:extLst>
+          </p:cNvPr>
+          <p:cNvSpPr/>
+          <p:nvPr/>
+        </p:nvSpPr>
+        <p:spPr>
+          <a:xfrm>
+            <a:off x="8534400" y="2743200"/>
+            <a:ext cx="3413760" cy="548640"/>
+          </a:xfrm>
+          <a:prstGeom prst="rect">
+            <a:avLst/>
+          </a:prstGeom>
+          <a:noFill/>
+          <a:ln/>
+        </p:spPr>
+        <p:txBody>
+          <a:bodyPr wrap="square" lIns="0" tIns="0" rIns="0" bIns="0" rtlCol="0" anchor="ctr"/>
+          <a:lstStyle/>
+          <a:p>
+            <a:pPr algn="ctr"/>
+            <a:r>
+              <a:rPr lang="en-US" sz="2667" b="1" dirty="0">
+                <a:solidFill>
+                  <a:srgbClr val="FFFFFF"/>
+                </a:solidFill>
+                <a:latin typeface="Helvetica Neue" pitchFamily="34" charset="0"/>
+                <a:ea typeface="Helvetica Neue" pitchFamily="34" charset="-122"/>
+                <a:cs typeface="Helvetica Neue" pitchFamily="34" charset="-120"/>
+              </a:rPr>
+              <a:t>Human Accountability</a:t>
+            </a:r>
+            <a:endParaRPr lang="en-US" sz="2667" dirty="0"/>
+          </a:p>
+        </p:txBody>
+      </p:sp>
+      <p:sp>
+        <p:nvSpPr>
+          <p:cNvPr id="12" name="Text 10">
+            <a:extLst>
+              <a:ext uri="{FF2B5EF4-FFF2-40B4-BE49-F238E27FC236}">
+                <a16:creationId xmlns:a16="http://schemas.microsoft.com/office/drawing/2014/main" id="{4FC01ED1-0536-9F2D-8231-EA3F752DF3E0}"/>
+              </a:ext>
+            </a:extLst>
+          </p:cNvPr>
+          <p:cNvSpPr/>
+          <p:nvPr/>
+        </p:nvSpPr>
+        <p:spPr>
+          <a:xfrm>
+            <a:off x="8534400" y="3291840"/>
+            <a:ext cx="3413760" cy="390144"/>
+          </a:xfrm>
+          <a:prstGeom prst="rect">
+            <a:avLst/>
+          </a:prstGeom>
+          <a:noFill/>
+          <a:ln/>
+        </p:spPr>
+        <p:txBody>
+          <a:bodyPr wrap="square" lIns="0" tIns="0" rIns="0" bIns="0" rtlCol="0" anchor="ctr"/>
+          <a:lstStyle/>
+          <a:p>
+            <a:pPr algn="ctr"/>
+            <a:r>
+              <a:rPr lang="en-US" sz="1333" i="1" dirty="0">
+                <a:solidFill>
+                  <a:srgbClr val="AACCFF"/>
+                </a:solidFill>
+                <a:latin typeface="Helvetica Neue" pitchFamily="34" charset="0"/>
+                <a:ea typeface="Helvetica Neue" pitchFamily="34" charset="-122"/>
+                <a:cs typeface="Helvetica Neue" pitchFamily="34" charset="-120"/>
+              </a:rPr>
+              <a:t>Observability at Every Decision Point</a:t>
+            </a:r>
+            <a:endParaRPr lang="en-US" sz="1333" dirty="0"/>
+          </a:p>
+        </p:txBody>
+      </p:sp>
+      <p:sp>
+        <p:nvSpPr>
+          <p:cNvPr id="13" name="Text 11">
+            <a:extLst>
+              <a:ext uri="{FF2B5EF4-FFF2-40B4-BE49-F238E27FC236}">
+                <a16:creationId xmlns:a16="http://schemas.microsoft.com/office/drawing/2014/main" id="{A4E4C259-97E8-E59B-77C9-A16931A1696B}"/>
+              </a:ext>
+            </a:extLst>
+          </p:cNvPr>
+          <p:cNvSpPr/>
+          <p:nvPr/>
+        </p:nvSpPr>
+        <p:spPr>
+          <a:xfrm>
+            <a:off x="8534400" y="4389120"/>
+            <a:ext cx="3413760" cy="390144"/>
+          </a:xfrm>
+          <a:prstGeom prst="rect">
+            <a:avLst/>
+          </a:prstGeom>
+          <a:noFill/>
+          <a:ln/>
+        </p:spPr>
+        <p:txBody>
+          <a:bodyPr wrap="square" lIns="0" tIns="0" rIns="0" bIns="0" rtlCol="0" anchor="ctr"/>
+          <a:lstStyle/>
+          <a:p>
+            <a:pPr algn="ctr"/>
+            <a:r>
+              <a:rPr lang="en-US" sz="1467" dirty="0">
+                <a:solidFill>
+                  <a:srgbClr val="AACCFF"/>
+                </a:solidFill>
+                <a:latin typeface="Helvetica Neue" pitchFamily="34" charset="0"/>
+                <a:ea typeface="Helvetica Neue" pitchFamily="34" charset="-122"/>
+                <a:cs typeface="Helvetica Neue" pitchFamily="34" charset="-120"/>
+              </a:rPr>
+              <a:t>April 2026</a:t>
+            </a:r>
+            <a:endParaRPr lang="en-US" sz="1467" dirty="0"/>
+          </a:p>
+        </p:txBody>
+      </p:sp>
+      <p:sp>
+        <p:nvSpPr>
+          <p:cNvPr id="14" name="Shape 12">
+            <a:extLst>
+              <a:ext uri="{FF2B5EF4-FFF2-40B4-BE49-F238E27FC236}">
+                <a16:creationId xmlns:a16="http://schemas.microsoft.com/office/drawing/2014/main" id="{1C0DCCB9-D5C8-59D9-60DC-33FB160A0969}"/>
+              </a:ext>
+            </a:extLst>
+          </p:cNvPr>
+          <p:cNvSpPr/>
+          <p:nvPr/>
+        </p:nvSpPr>
+        <p:spPr>
+          <a:xfrm>
+            <a:off x="219456" y="6437376"/>
+            <a:ext cx="11753088" cy="0"/>
+          </a:xfrm>
+          <a:prstGeom prst="line">
+            <a:avLst/>
+          </a:prstGeom>
+          <a:noFill/>
+          <a:ln w="12700">
+            <a:solidFill>
+              <a:srgbClr val="0080FF"/>
+            </a:solidFill>
+            <a:prstDash val="solid"/>
+          </a:ln>
+        </p:spPr>
+        <p:txBody>
+          <a:bodyPr/>
+          <a:lstStyle/>
+          <a:p>
+            <a:endParaRPr lang="en-US" sz="2400"/>
+          </a:p>
+        </p:txBody>
+      </p:sp>
+      <p:pic>
+        <p:nvPicPr>
+          <p:cNvPr id="15" name="Image 0" descr="preencoded.png">
+            <a:extLst>
+              <a:ext uri="{FF2B5EF4-FFF2-40B4-BE49-F238E27FC236}">
+                <a16:creationId xmlns:a16="http://schemas.microsoft.com/office/drawing/2014/main" id="{A7B92BF7-0DA6-A44C-FB53-FE5334F09982}"/>
+              </a:ext>
+            </a:extLst>
+          </p:cNvPr>
+          <p:cNvPicPr>
+            <a:picLocks noChangeAspect="1"/>
+          </p:cNvPicPr>
+          <p:nvPr/>
+        </p:nvPicPr>
+        <p:blipFill>
+          <a:blip r:embed="rId3"/>
+          <a:stretch>
+            <a:fillRect/>
+          </a:stretch>
+        </p:blipFill>
+        <p:spPr>
+          <a:xfrm>
+            <a:off x="219456" y="6486144"/>
+            <a:ext cx="585216" cy="316992"/>
+          </a:xfrm>
+          <a:prstGeom prst="rect">
+            <a:avLst/>
+          </a:prstGeom>
+        </p:spPr>
+      </p:pic>
+      <p:sp>
+        <p:nvSpPr>
+          <p:cNvPr id="16" name="Text 13">
+            <a:extLst>
+              <a:ext uri="{FF2B5EF4-FFF2-40B4-BE49-F238E27FC236}">
+                <a16:creationId xmlns:a16="http://schemas.microsoft.com/office/drawing/2014/main" id="{2C8E44C8-2865-A838-F3A4-B8BAD376C6CE}"/>
+              </a:ext>
+            </a:extLst>
+          </p:cNvPr>
+          <p:cNvSpPr/>
+          <p:nvPr/>
+        </p:nvSpPr>
+        <p:spPr>
+          <a:xfrm>
+            <a:off x="8290560" y="6498336"/>
+            <a:ext cx="3657600" cy="268224"/>
+          </a:xfrm>
+          <a:prstGeom prst="rect">
+            <a:avLst/>
+          </a:prstGeom>
+          <a:noFill/>
+          <a:ln/>
+        </p:spPr>
+        <p:txBody>
+          <a:bodyPr wrap="square" lIns="0" tIns="0" rIns="0" bIns="0" rtlCol="0" anchor="ctr"/>
+          <a:lstStyle/>
+          <a:p>
+            <a:pPr algn="r"/>
+            <a:r>
+              <a:rPr lang="en-US" sz="1000" dirty="0">
+                <a:solidFill>
+                  <a:srgbClr val="AACCFF"/>
+                </a:solidFill>
+                <a:latin typeface="Helvetica Neue" pitchFamily="34" charset="0"/>
+                <a:ea typeface="Helvetica Neue" pitchFamily="34" charset="-122"/>
+                <a:cs typeface="Helvetica Neue" pitchFamily="34" charset="-120"/>
+              </a:rPr>
+              <a:t>Copyright © Database Solutions, Inc.</a:t>
+            </a:r>
+            <a:endParaRPr lang="en-US" sz="1000" dirty="0"/>
+          </a:p>
+        </p:txBody>
+      </p:sp>
+    </p:spTree>
+    <p:extLst>
+      <p:ext uri="{BB962C8B-B14F-4D97-AF65-F5344CB8AC3E}">
+        <p14:creationId xmlns:p14="http://schemas.microsoft.com/office/powerpoint/2010/main" val="1549711550"/>
+      </p:ext>
+    </p:extLst>
+  </p:cSld>
+  <p:clrMapOvr>
+    <a:masterClrMapping/>
+  </p:clrMapOvr>
+</p:sld>
+</file>
+
+<file path=ppt/slides/slide4.xml><?xml version="1.0" encoding="utf-8"?>
+<p:sld xmlns:a="http://schemas.openxmlformats.org/drawingml/2006/main" xmlns:r="http://schemas.openxmlformats.org/officeDocument/2006/relationships" xmlns:p="http://schemas.openxmlformats.org/presentationml/2006/main">
+  <p:cSld>
+    <p:bg>
+      <p:bgPr>
+        <a:solidFill>
           <a:srgbClr val="203445"/>
         </a:solidFill>
         <a:effectLst/>
@@ -3536,7 +5177,7 @@
 </p:sld>
 </file>
 
-<file path=ppt/slides/slide3.xml><?xml version="1.0" encoding="utf-8"?>
+<file path=ppt/slides/slide5.xml><?xml version="1.0" encoding="utf-8"?>
 <p:sld xmlns:a="http://schemas.openxmlformats.org/drawingml/2006/main" xmlns:r="http://schemas.openxmlformats.org/officeDocument/2006/relationships" xmlns:p="http://schemas.openxmlformats.org/presentationml/2006/main">
   <p:cSld>
     <p:spTree>
@@ -4282,4 +5923,319 @@
     </a:ext>
   </a:extLst>
 </a:theme>
+</file>
+
+<file path=ppt/theme/theme2.xml><?xml version="1.0" encoding="utf-8"?>
+<a:theme xmlns:a="http://schemas.openxmlformats.org/drawingml/2006/main" name="Office Theme">
+  <a:themeElements>
+    <a:clrScheme name="Office">
+      <a:dk1>
+        <a:sysClr val="windowText" lastClr="000000"/>
+      </a:dk1>
+      <a:lt1>
+        <a:sysClr val="window" lastClr="FFFFFF"/>
+      </a:lt1>
+      <a:dk2>
+        <a:srgbClr val="0E2841"/>
+      </a:dk2>
+      <a:lt2>
+        <a:srgbClr val="E8E8E8"/>
+      </a:lt2>
+      <a:accent1>
+        <a:srgbClr val="156082"/>
+      </a:accent1>
+      <a:accent2>
+        <a:srgbClr val="E97132"/>
+      </a:accent2>
+      <a:accent3>
+        <a:srgbClr val="196B24"/>
+      </a:accent3>
+      <a:accent4>
+        <a:srgbClr val="0F9ED5"/>
+      </a:accent4>
+      <a:accent5>
+        <a:srgbClr val="A02B93"/>
+      </a:accent5>
+      <a:accent6>
+        <a:srgbClr val="4EA72E"/>
+      </a:accent6>
+      <a:hlink>
+        <a:srgbClr val="467886"/>
+      </a:hlink>
+      <a:folHlink>
+        <a:srgbClr val="96607D"/>
+      </a:folHlink>
+    </a:clrScheme>
+    <a:fontScheme name="Office">
+      <a:majorFont>
+        <a:latin typeface="Aptos Display" panose="02110004020202020204"/>
+        <a:ea typeface=""/>
+        <a:cs typeface=""/>
+        <a:font script="Jpan" typeface="游ゴシック Light"/>
+        <a:font script="Hang" typeface="맑은 고딕"/>
+        <a:font script="Hans" typeface="等线 Light"/>
+        <a:font script="Hant" typeface="新細明體"/>
+        <a:font script="Arab" typeface="Times New Roman"/>
+        <a:font script="Hebr" typeface="Times New Roman"/>
+        <a:font script="Thai" typeface="Angsana New"/>
+        <a:font script="Ethi" typeface="Nyala"/>
+        <a:font script="Beng" typeface="Vrinda"/>
+        <a:font script="Gujr" typeface="Shruti"/>
+        <a:font script="Khmr" typeface="MoolBoran"/>
+        <a:font script="Knda" typeface="Tunga"/>
+        <a:font script="Guru" typeface="Raavi"/>
+        <a:font script="Cans" typeface="Euphemia"/>
+        <a:font script="Cher" typeface="Plantagenet Cherokee"/>
+        <a:font script="Yiii" typeface="Microsoft Yi Baiti"/>
+        <a:font script="Tibt" typeface="Microsoft Himalaya"/>
+        <a:font script="Thaa" typeface="MV Boli"/>
+        <a:font script="Deva" typeface="Mangal"/>
+        <a:font script="Telu" typeface="Gautami"/>
+        <a:font script="Taml" typeface="Latha"/>
+        <a:font script="Syrc" typeface="Estrangelo Edessa"/>
+        <a:font script="Orya" typeface="Kalinga"/>
+        <a:font script="Mlym" typeface="Kartika"/>
+        <a:font script="Laoo" typeface="DokChampa"/>
+        <a:font script="Sinh" typeface="Iskoola Pota"/>
+        <a:font script="Mong" typeface="Mongolian Baiti"/>
+        <a:font script="Viet" typeface="Times New Roman"/>
+        <a:font script="Uigh" typeface="Microsoft Uighur"/>
+        <a:font script="Geor" typeface="Sylfaen"/>
+        <a:font script="Armn" typeface="Arial"/>
+        <a:font script="Bugi" typeface="Leelawadee UI"/>
+        <a:font script="Bopo" typeface="Microsoft JhengHei"/>
+        <a:font script="Java" typeface="Javanese Text"/>
+        <a:font script="Lisu" typeface="Segoe UI"/>
+        <a:font script="Mymr" typeface="Myanmar Text"/>
+        <a:font script="Nkoo" typeface="Ebrima"/>
+        <a:font script="Olck" typeface="Nirmala UI"/>
+        <a:font script="Osma" typeface="Ebrima"/>
+        <a:font script="Phag" typeface="Phagspa"/>
+        <a:font script="Syrn" typeface="Estrangelo Edessa"/>
+        <a:font script="Syrj" typeface="Estrangelo Edessa"/>
+        <a:font script="Syre" typeface="Estrangelo Edessa"/>
+        <a:font script="Sora" typeface="Nirmala UI"/>
+        <a:font script="Tale" typeface="Microsoft Tai Le"/>
+        <a:font script="Talu" typeface="Microsoft New Tai Lue"/>
+        <a:font script="Tfng" typeface="Ebrima"/>
+      </a:majorFont>
+      <a:minorFont>
+        <a:latin typeface="Aptos" panose="02110004020202020204"/>
+        <a:ea typeface=""/>
+        <a:cs typeface=""/>
+        <a:font script="Jpan" typeface="游ゴシック"/>
+        <a:font script="Hang" typeface="맑은 고딕"/>
+        <a:font script="Hans" typeface="等线"/>
+        <a:font script="Hant" typeface="新細明體"/>
+        <a:font script="Arab" typeface="Arial"/>
+        <a:font script="Hebr" typeface="Arial"/>
+        <a:font script="Thai" typeface="Cordia New"/>
+        <a:font script="Ethi" typeface="Nyala"/>
+        <a:font script="Beng" typeface="Vrinda"/>
+        <a:font script="Gujr" typeface="Shruti"/>
+        <a:font script="Khmr" typeface="DaunPenh"/>
+        <a:font script="Knda" typeface="Tunga"/>
+        <a:font script="Guru" typeface="Raavi"/>
+        <a:font script="Cans" typeface="Euphemia"/>
+        <a:font script="Cher" typeface="Plantagenet Cherokee"/>
+        <a:font script="Yiii" typeface="Microsoft Yi Baiti"/>
+        <a:font script="Tibt" typeface="Microsoft Himalaya"/>
+        <a:font script="Thaa" typeface="MV Boli"/>
+        <a:font script="Deva" typeface="Mangal"/>
+        <a:font script="Telu" typeface="Gautami"/>
+        <a:font script="Taml" typeface="Latha"/>
+        <a:font script="Syrc" typeface="Estrangelo Edessa"/>
+        <a:font script="Orya" typeface="Kalinga"/>
+        <a:font script="Mlym" typeface="Kartika"/>
+        <a:font script="Laoo" typeface="DokChampa"/>
+        <a:font script="Sinh" typeface="Iskoola Pota"/>
+        <a:font script="Mong" typeface="Mongolian Baiti"/>
+        <a:font script="Viet" typeface="Arial"/>
+        <a:font script="Uigh" typeface="Microsoft Uighur"/>
+        <a:font script="Geor" typeface="Sylfaen"/>
+        <a:font script="Armn" typeface="Arial"/>
+        <a:font script="Bugi" typeface="Leelawadee UI"/>
+        <a:font script="Bopo" typeface="Microsoft JhengHei"/>
+        <a:font script="Java" typeface="Javanese Text"/>
+        <a:font script="Lisu" typeface="Segoe UI"/>
+        <a:font script="Mymr" typeface="Myanmar Text"/>
+        <a:font script="Nkoo" typeface="Ebrima"/>
+        <a:font script="Olck" typeface="Nirmala UI"/>
+        <a:font script="Osma" typeface="Ebrima"/>
+        <a:font script="Phag" typeface="Phagspa"/>
+        <a:font script="Syrn" typeface="Estrangelo Edessa"/>
+        <a:font script="Syrj" typeface="Estrangelo Edessa"/>
+        <a:font script="Syre" typeface="Estrangelo Edessa"/>
+        <a:font script="Sora" typeface="Nirmala UI"/>
+        <a:font script="Tale" typeface="Microsoft Tai Le"/>
+        <a:font script="Talu" typeface="Microsoft New Tai Lue"/>
+        <a:font script="Tfng" typeface="Ebrima"/>
+      </a:minorFont>
+    </a:fontScheme>
+    <a:fmtScheme name="Office">
+      <a:fillStyleLst>
+        <a:solidFill>
+          <a:schemeClr val="phClr"/>
+        </a:solidFill>
+        <a:gradFill rotWithShape="1">
+          <a:gsLst>
+            <a:gs pos="0">
+              <a:schemeClr val="phClr">
+                <a:lumMod val="110000"/>
+                <a:satMod val="105000"/>
+                <a:tint val="67000"/>
+              </a:schemeClr>
+            </a:gs>
+            <a:gs pos="50000">
+              <a:schemeClr val="phClr">
+                <a:lumMod val="105000"/>
+                <a:satMod val="103000"/>
+                <a:tint val="73000"/>
+              </a:schemeClr>
+            </a:gs>
+            <a:gs pos="100000">
+              <a:schemeClr val="phClr">
+                <a:lumMod val="105000"/>
+                <a:satMod val="109000"/>
+                <a:tint val="81000"/>
+              </a:schemeClr>
+            </a:gs>
+          </a:gsLst>
+          <a:lin ang="5400000" scaled="0"/>
+        </a:gradFill>
+        <a:gradFill rotWithShape="1">
+          <a:gsLst>
+            <a:gs pos="0">
+              <a:schemeClr val="phClr">
+                <a:satMod val="103000"/>
+                <a:lumMod val="102000"/>
+                <a:tint val="94000"/>
+              </a:schemeClr>
+            </a:gs>
+            <a:gs pos="50000">
+              <a:schemeClr val="phClr">
+                <a:satMod val="110000"/>
+                <a:lumMod val="100000"/>
+                <a:shade val="100000"/>
+              </a:schemeClr>
+            </a:gs>
+            <a:gs pos="100000">
+              <a:schemeClr val="phClr">
+                <a:lumMod val="99000"/>
+                <a:satMod val="120000"/>
+                <a:shade val="78000"/>
+              </a:schemeClr>
+            </a:gs>
+          </a:gsLst>
+          <a:lin ang="5400000" scaled="0"/>
+        </a:gradFill>
+      </a:fillStyleLst>
+      <a:lnStyleLst>
+        <a:ln w="12700" cap="flat" cmpd="sng" algn="ctr">
+          <a:solidFill>
+            <a:schemeClr val="phClr"/>
+          </a:solidFill>
+          <a:prstDash val="solid"/>
+          <a:miter lim="800000"/>
+        </a:ln>
+        <a:ln w="19050" cap="flat" cmpd="sng" algn="ctr">
+          <a:solidFill>
+            <a:schemeClr val="phClr"/>
+          </a:solidFill>
+          <a:prstDash val="solid"/>
+          <a:miter lim="800000"/>
+        </a:ln>
+        <a:ln w="25400" cap="flat" cmpd="sng" algn="ctr">
+          <a:solidFill>
+            <a:schemeClr val="phClr"/>
+          </a:solidFill>
+          <a:prstDash val="solid"/>
+          <a:miter lim="800000"/>
+        </a:ln>
+      </a:lnStyleLst>
+      <a:effectStyleLst>
+        <a:effectStyle>
+          <a:effectLst/>
+        </a:effectStyle>
+        <a:effectStyle>
+          <a:effectLst/>
+        </a:effectStyle>
+        <a:effectStyle>
+          <a:effectLst>
+            <a:outerShdw blurRad="57150" dist="19050" dir="5400000" algn="ctr" rotWithShape="0">
+              <a:srgbClr val="000000">
+                <a:alpha val="63000"/>
+              </a:srgbClr>
+            </a:outerShdw>
+          </a:effectLst>
+        </a:effectStyle>
+      </a:effectStyleLst>
+      <a:bgFillStyleLst>
+        <a:solidFill>
+          <a:schemeClr val="phClr"/>
+        </a:solidFill>
+        <a:solidFill>
+          <a:schemeClr val="phClr">
+            <a:tint val="95000"/>
+            <a:satMod val="170000"/>
+          </a:schemeClr>
+        </a:solidFill>
+        <a:gradFill rotWithShape="1">
+          <a:gsLst>
+            <a:gs pos="0">
+              <a:schemeClr val="phClr">
+                <a:tint val="93000"/>
+                <a:satMod val="150000"/>
+                <a:shade val="98000"/>
+                <a:lumMod val="102000"/>
+              </a:schemeClr>
+            </a:gs>
+            <a:gs pos="50000">
+              <a:schemeClr val="phClr">
+                <a:tint val="98000"/>
+                <a:satMod val="130000"/>
+                <a:shade val="90000"/>
+                <a:lumMod val="103000"/>
+              </a:schemeClr>
+            </a:gs>
+            <a:gs pos="100000">
+              <a:schemeClr val="phClr">
+                <a:shade val="63000"/>
+                <a:satMod val="120000"/>
+              </a:schemeClr>
+            </a:gs>
+          </a:gsLst>
+          <a:lin ang="5400000" scaled="0"/>
+        </a:gradFill>
+      </a:bgFillStyleLst>
+    </a:fmtScheme>
+  </a:themeElements>
+  <a:objectDefaults>
+    <a:lnDef>
+      <a:spPr/>
+      <a:bodyPr/>
+      <a:lstStyle/>
+      <a:style>
+        <a:lnRef idx="2">
+          <a:schemeClr val="accent1"/>
+        </a:lnRef>
+        <a:fillRef idx="0">
+          <a:schemeClr val="accent1"/>
+        </a:fillRef>
+        <a:effectRef idx="1">
+          <a:schemeClr val="accent1"/>
+        </a:effectRef>
+        <a:fontRef idx="minor">
+          <a:schemeClr val="tx1"/>
+        </a:fontRef>
+      </a:style>
+    </a:lnDef>
+  </a:objectDefaults>
+  <a:extraClrSchemeLst/>
+  <a:extLst>
+    <a:ext uri="{05A4C25C-085E-4340-85A3-A5531E510DB2}">
+      <thm15:themeFamily xmlns:thm15="http://schemas.microsoft.com/office/thememl/2012/main" name="Office Theme" id="{2E142A2C-CD16-42D6-873A-C26D2A0506FA}" vid="{1BDDFF52-6CD6-40A5-AB3C-68EB2F1E4D0A}"/>
+    </a:ext>
+  </a:extLst>
+</a:theme>
 </file>
</xml_diff>